<commit_message>
added the files with proper name
</commit_message>
<xml_diff>
--- a/Presentation/Unveiling-Tabular-Foundation-Models-An-In-depth-Analysis-of-TabPFN.pptx
+++ b/Presentation/Unveiling-Tabular-Foundation-Models-An-In-depth-Analysis-of-TabPFN.pptx
@@ -1463,6 +1463,13 @@
           </a:solidFill>
           <a:ln/>
         </p:spPr>
+        <p:txBody>
+          <a:bodyPr/>
+          <a:lstStyle/>
+          <a:p>
+            <a:endParaRPr lang="en-IN"/>
+          </a:p>
+        </p:txBody>
       </p:sp>
       <p:sp>
         <p:nvSpPr>
@@ -1483,6 +1490,13 @@
           </a:solidFill>
           <a:ln/>
         </p:spPr>
+        <p:txBody>
+          <a:bodyPr/>
+          <a:lstStyle/>
+          <a:p>
+            <a:endParaRPr lang="en-IN"/>
+          </a:p>
+        </p:txBody>
       </p:sp>
       <p:pic>
         <p:nvPicPr>
@@ -4400,10 +4414,10 @@
       </p:sp>
       <p:pic>
         <p:nvPicPr>
-          <p:cNvPr id="18" name="Picture 17">
+          <p:cNvPr id="4" name="Picture 3" descr="A graph with a line&#10;&#10;AI-generated content may be incorrect.">
             <a:extLst>
               <a:ext uri="{FF2B5EF4-FFF2-40B4-BE49-F238E27FC236}">
-                <a16:creationId xmlns:a16="http://schemas.microsoft.com/office/drawing/2014/main" id="{585C2DD4-C0D3-BA05-84AB-65D1CD54CD0B}"/>
+                <a16:creationId xmlns:a16="http://schemas.microsoft.com/office/drawing/2014/main" id="{8ED4DF4D-00EA-D9D0-D0F0-74F7565A563D}"/>
               </a:ext>
             </a:extLst>
           </p:cNvPr>
@@ -4420,8 +4434,8 @@
         </p:blipFill>
         <p:spPr>
           <a:xfrm>
-            <a:off x="1884172" y="1592756"/>
-            <a:ext cx="10862056" cy="5642134"/>
+            <a:off x="427121" y="1820606"/>
+            <a:ext cx="13776158" cy="4588387"/>
           </a:xfrm>
           <a:prstGeom prst="rect">
             <a:avLst/>
@@ -4916,7 +4930,7 @@
         </p:blipFill>
         <p:spPr>
           <a:xfrm>
-            <a:off x="7431218" y="1518345"/>
+            <a:off x="7431218" y="1758985"/>
             <a:ext cx="6557673" cy="4708177"/>
           </a:xfrm>
           <a:prstGeom prst="rect">
@@ -5182,7 +5196,7 @@
                 <a:ea typeface="Roboto" pitchFamily="34" charset="-122"/>
                 <a:cs typeface="Roboto" pitchFamily="34" charset="-120"/>
               </a:rPr>
-              <a:t>We curated a diverse suite of 7 tabular datasets, encompassing both classification and regression tasks, with varying sample sizes and feature dimensions. Each dataset underwent meticulous preprocessing to ensure consistency and eliminate biases before model application.</a:t>
+              <a:t>We curated a diverse suite of 5 tabular datasets, encompassing both classification and regression tasks, with varying sample sizes and feature dimensions. Each dataset underwent meticulous preprocessing to ensure consistency and eliminate biases before model application.</a:t>
             </a:r>
             <a:endParaRPr lang="en-US" sz="1250" dirty="0"/>
           </a:p>

</xml_diff>